<commit_message>
Update handout PPTX and PDF with latest layout fixes
</commit_message>
<xml_diff>
--- a/mandala_l1_handout.pptx
+++ b/mandala_l1_handout.pptx
@@ -5531,7 +5531,7 @@
         <p:spPr>
           <a:xfrm>
             <a:off x="502920" y="8266175"/>
-            <a:ext cx="6556248" cy="969264"/>
+            <a:ext cx="6556248" cy="1188720"/>
           </a:xfrm>
           <a:prstGeom prst="roundRect">
             <a:avLst/>
@@ -5614,7 +5614,7 @@
         <p:spPr>
           <a:xfrm>
             <a:off x="667512" y="8650224"/>
-            <a:ext cx="6227064" cy="512064"/>
+            <a:ext cx="6227064" cy="731520"/>
           </a:xfrm>
           <a:prstGeom prst="rect">
             <a:avLst/>
@@ -7750,7 +7750,7 @@
         <p:spPr>
           <a:xfrm>
             <a:off x="502920" y="8266175"/>
-            <a:ext cx="6556248" cy="969264"/>
+            <a:ext cx="6556248" cy="1188720"/>
           </a:xfrm>
           <a:prstGeom prst="roundRect">
             <a:avLst/>
@@ -7833,7 +7833,7 @@
         <p:spPr>
           <a:xfrm>
             <a:off x="667512" y="8650224"/>
-            <a:ext cx="6227064" cy="512064"/>
+            <a:ext cx="6227064" cy="731520"/>
           </a:xfrm>
           <a:prstGeom prst="rect">
             <a:avLst/>
@@ -9969,7 +9969,7 @@
         <p:spPr>
           <a:xfrm>
             <a:off x="502920" y="8266175"/>
-            <a:ext cx="6556248" cy="969264"/>
+            <a:ext cx="6556248" cy="1188720"/>
           </a:xfrm>
           <a:prstGeom prst="roundRect">
             <a:avLst/>
@@ -10052,7 +10052,7 @@
         <p:spPr>
           <a:xfrm>
             <a:off x="667512" y="8650224"/>
-            <a:ext cx="6227064" cy="512064"/>
+            <a:ext cx="6227064" cy="731520"/>
           </a:xfrm>
           <a:prstGeom prst="rect">
             <a:avLst/>
@@ -12188,7 +12188,7 @@
         <p:spPr>
           <a:xfrm>
             <a:off x="502920" y="8266175"/>
-            <a:ext cx="6556248" cy="969264"/>
+            <a:ext cx="6556248" cy="1188720"/>
           </a:xfrm>
           <a:prstGeom prst="roundRect">
             <a:avLst/>
@@ -12271,7 +12271,7 @@
         <p:spPr>
           <a:xfrm>
             <a:off x="667512" y="8650224"/>
-            <a:ext cx="6227064" cy="512064"/>
+            <a:ext cx="6227064" cy="731520"/>
           </a:xfrm>
           <a:prstGeom prst="rect">
             <a:avLst/>
@@ -14407,7 +14407,7 @@
         <p:spPr>
           <a:xfrm>
             <a:off x="502920" y="8266175"/>
-            <a:ext cx="6556248" cy="969264"/>
+            <a:ext cx="6556248" cy="1188720"/>
           </a:xfrm>
           <a:prstGeom prst="roundRect">
             <a:avLst/>
@@ -14490,7 +14490,7 @@
         <p:spPr>
           <a:xfrm>
             <a:off x="667512" y="8650224"/>
-            <a:ext cx="6227064" cy="512064"/>
+            <a:ext cx="6227064" cy="731520"/>
           </a:xfrm>
           <a:prstGeom prst="rect">
             <a:avLst/>
@@ -16626,7 +16626,7 @@
         <p:spPr>
           <a:xfrm>
             <a:off x="502920" y="8266175"/>
-            <a:ext cx="6556248" cy="969264"/>
+            <a:ext cx="6556248" cy="1188720"/>
           </a:xfrm>
           <a:prstGeom prst="roundRect">
             <a:avLst/>
@@ -16709,7 +16709,7 @@
         <p:spPr>
           <a:xfrm>
             <a:off x="667512" y="8650224"/>
-            <a:ext cx="6227064" cy="512064"/>
+            <a:ext cx="6227064" cy="731520"/>
           </a:xfrm>
           <a:prstGeom prst="rect">
             <a:avLst/>
@@ -18845,7 +18845,7 @@
         <p:spPr>
           <a:xfrm>
             <a:off x="502920" y="8266175"/>
-            <a:ext cx="6556248" cy="969264"/>
+            <a:ext cx="6556248" cy="1188720"/>
           </a:xfrm>
           <a:prstGeom prst="roundRect">
             <a:avLst/>
@@ -18928,7 +18928,7 @@
         <p:spPr>
           <a:xfrm>
             <a:off x="667512" y="8650224"/>
-            <a:ext cx="6227064" cy="512064"/>
+            <a:ext cx="6227064" cy="731520"/>
           </a:xfrm>
           <a:prstGeom prst="rect">
             <a:avLst/>
@@ -21064,7 +21064,7 @@
         <p:spPr>
           <a:xfrm>
             <a:off x="502920" y="8266175"/>
-            <a:ext cx="6556248" cy="969264"/>
+            <a:ext cx="6556248" cy="1188720"/>
           </a:xfrm>
           <a:prstGeom prst="roundRect">
             <a:avLst/>
@@ -21147,7 +21147,7 @@
         <p:spPr>
           <a:xfrm>
             <a:off x="667512" y="8650224"/>
-            <a:ext cx="6227064" cy="512064"/>
+            <a:ext cx="6227064" cy="731520"/>
           </a:xfrm>
           <a:prstGeom prst="rect">
             <a:avLst/>
@@ -22866,7 +22866,7 @@
         <p:spPr>
           <a:xfrm>
             <a:off x="502920" y="1078992"/>
-            <a:ext cx="6556248" cy="329184"/>
+            <a:ext cx="6556248" cy="493776"/>
           </a:xfrm>
           <a:prstGeom prst="rect">
             <a:avLst/>
@@ -22913,7 +22913,7 @@
         </p:blipFill>
         <p:spPr>
           <a:xfrm>
-            <a:off x="502920" y="1481328"/>
+            <a:off x="502920" y="1682496"/>
             <a:ext cx="1570482" cy="1570482"/>
           </a:xfrm>
           <a:prstGeom prst="rect">
@@ -22932,7 +22932,7 @@
         </p:nvSpPr>
         <p:spPr>
           <a:xfrm>
-            <a:off x="502920" y="3106674"/>
+            <a:off x="502920" y="3307842"/>
             <a:ext cx="1570482" cy="310896"/>
           </a:xfrm>
           <a:prstGeom prst="rect">
@@ -22971,7 +22971,7 @@
         </p:nvSpPr>
         <p:spPr>
           <a:xfrm>
-            <a:off x="502920" y="3417570"/>
+            <a:off x="502920" y="3618738"/>
             <a:ext cx="1570482" cy="256032"/>
           </a:xfrm>
           <a:prstGeom prst="rect">
@@ -23019,7 +23019,7 @@
         </p:blipFill>
         <p:spPr>
           <a:xfrm>
-            <a:off x="2164842" y="1481328"/>
+            <a:off x="2164842" y="1682496"/>
             <a:ext cx="1570482" cy="1570482"/>
           </a:xfrm>
           <a:prstGeom prst="rect">
@@ -23038,7 +23038,7 @@
         </p:nvSpPr>
         <p:spPr>
           <a:xfrm>
-            <a:off x="2164842" y="3106674"/>
+            <a:off x="2164842" y="3307842"/>
             <a:ext cx="1570482" cy="310896"/>
           </a:xfrm>
           <a:prstGeom prst="rect">
@@ -23077,7 +23077,7 @@
         </p:nvSpPr>
         <p:spPr>
           <a:xfrm>
-            <a:off x="2164842" y="3417570"/>
+            <a:off x="2164842" y="3618738"/>
             <a:ext cx="1570482" cy="256032"/>
           </a:xfrm>
           <a:prstGeom prst="rect">
@@ -23125,7 +23125,7 @@
         </p:blipFill>
         <p:spPr>
           <a:xfrm>
-            <a:off x="3826764" y="1481328"/>
+            <a:off x="3826764" y="1682496"/>
             <a:ext cx="1570482" cy="1570482"/>
           </a:xfrm>
           <a:prstGeom prst="rect">
@@ -23144,7 +23144,7 @@
         </p:nvSpPr>
         <p:spPr>
           <a:xfrm>
-            <a:off x="3826764" y="3106674"/>
+            <a:off x="3826764" y="3307842"/>
             <a:ext cx="1570482" cy="310896"/>
           </a:xfrm>
           <a:prstGeom prst="rect">
@@ -23183,7 +23183,7 @@
         </p:nvSpPr>
         <p:spPr>
           <a:xfrm>
-            <a:off x="3826764" y="3417570"/>
+            <a:off x="3826764" y="3618738"/>
             <a:ext cx="1570482" cy="256032"/>
           </a:xfrm>
           <a:prstGeom prst="rect">
@@ -23231,7 +23231,7 @@
         </p:blipFill>
         <p:spPr>
           <a:xfrm>
-            <a:off x="5488686" y="1481328"/>
+            <a:off x="5488686" y="1682496"/>
             <a:ext cx="1570482" cy="1570482"/>
           </a:xfrm>
           <a:prstGeom prst="rect">
@@ -23250,7 +23250,7 @@
         </p:nvSpPr>
         <p:spPr>
           <a:xfrm>
-            <a:off x="5488686" y="3106674"/>
+            <a:off x="5488686" y="3307842"/>
             <a:ext cx="1570482" cy="310896"/>
           </a:xfrm>
           <a:prstGeom prst="rect">
@@ -23289,7 +23289,7 @@
         </p:nvSpPr>
         <p:spPr>
           <a:xfrm>
-            <a:off x="5488686" y="3417570"/>
+            <a:off x="5488686" y="3618738"/>
             <a:ext cx="1570482" cy="256032"/>
           </a:xfrm>
           <a:prstGeom prst="rect">
@@ -23328,7 +23328,7 @@
         </p:nvSpPr>
         <p:spPr>
           <a:xfrm>
-            <a:off x="502920" y="3746754"/>
+            <a:off x="502920" y="3947922"/>
             <a:ext cx="6556248" cy="1170432"/>
           </a:xfrm>
           <a:prstGeom prst="rect">
@@ -25464,7 +25464,7 @@
         </p:nvSpPr>
         <p:spPr>
           <a:xfrm>
-            <a:off x="502920" y="1645920"/>
+            <a:off x="502920" y="1828800"/>
             <a:ext cx="3177540" cy="1298448"/>
           </a:xfrm>
           <a:prstGeom prst="roundRect">
@@ -25519,7 +25519,7 @@
         </p:blipFill>
         <p:spPr>
           <a:xfrm>
-            <a:off x="557784" y="1837943"/>
+            <a:off x="557784" y="2020824"/>
             <a:ext cx="914400" cy="914400"/>
           </a:xfrm>
           <a:prstGeom prst="rect">
@@ -25538,7 +25538,7 @@
         </p:nvSpPr>
         <p:spPr>
           <a:xfrm>
-            <a:off x="1581912" y="1737360"/>
+            <a:off x="1581912" y="1920240"/>
             <a:ext cx="2043684" cy="384048"/>
           </a:xfrm>
           <a:prstGeom prst="rect">
@@ -25577,7 +25577,7 @@
         </p:nvSpPr>
         <p:spPr>
           <a:xfrm>
-            <a:off x="1581912" y="2176272"/>
+            <a:off x="1581912" y="2359152"/>
             <a:ext cx="2043684" cy="694944"/>
           </a:xfrm>
           <a:prstGeom prst="rect">
@@ -25616,7 +25616,7 @@
         </p:nvSpPr>
         <p:spPr>
           <a:xfrm>
-            <a:off x="3881628" y="1645920"/>
+            <a:off x="3881628" y="1828800"/>
             <a:ext cx="3177540" cy="1298448"/>
           </a:xfrm>
           <a:prstGeom prst="roundRect">
@@ -25671,7 +25671,7 @@
         </p:blipFill>
         <p:spPr>
           <a:xfrm>
-            <a:off x="3936491" y="1837943"/>
+            <a:off x="3936491" y="2020824"/>
             <a:ext cx="914400" cy="914400"/>
           </a:xfrm>
           <a:prstGeom prst="rect">
@@ -25690,7 +25690,7 @@
         </p:nvSpPr>
         <p:spPr>
           <a:xfrm>
-            <a:off x="4960620" y="1737360"/>
+            <a:off x="4960620" y="1920240"/>
             <a:ext cx="2043684" cy="384048"/>
           </a:xfrm>
           <a:prstGeom prst="rect">
@@ -25729,7 +25729,7 @@
         </p:nvSpPr>
         <p:spPr>
           <a:xfrm>
-            <a:off x="4960620" y="2176272"/>
+            <a:off x="4960620" y="2359152"/>
             <a:ext cx="2043684" cy="694944"/>
           </a:xfrm>
           <a:prstGeom prst="rect">
@@ -25768,7 +25768,7 @@
         </p:nvSpPr>
         <p:spPr>
           <a:xfrm>
-            <a:off x="502920" y="3145536"/>
+            <a:off x="502920" y="3328415"/>
             <a:ext cx="3177540" cy="1298448"/>
           </a:xfrm>
           <a:prstGeom prst="roundRect">
@@ -25823,7 +25823,7 @@
         </p:blipFill>
         <p:spPr>
           <a:xfrm>
-            <a:off x="557784" y="3337560"/>
+            <a:off x="557784" y="3520439"/>
             <a:ext cx="914400" cy="914400"/>
           </a:xfrm>
           <a:prstGeom prst="rect">
@@ -25842,7 +25842,7 @@
         </p:nvSpPr>
         <p:spPr>
           <a:xfrm>
-            <a:off x="1581912" y="3236976"/>
+            <a:off x="1581912" y="3419856"/>
             <a:ext cx="2043684" cy="384048"/>
           </a:xfrm>
           <a:prstGeom prst="rect">
@@ -25881,7 +25881,7 @@
         </p:nvSpPr>
         <p:spPr>
           <a:xfrm>
-            <a:off x="1581912" y="3675887"/>
+            <a:off x="1581912" y="3858768"/>
             <a:ext cx="2043684" cy="694944"/>
           </a:xfrm>
           <a:prstGeom prst="rect">
@@ -25920,7 +25920,7 @@
         </p:nvSpPr>
         <p:spPr>
           <a:xfrm>
-            <a:off x="3881628" y="3145536"/>
+            <a:off x="3881628" y="3328415"/>
             <a:ext cx="3177540" cy="1298448"/>
           </a:xfrm>
           <a:prstGeom prst="roundRect">
@@ -25975,7 +25975,7 @@
         </p:blipFill>
         <p:spPr>
           <a:xfrm>
-            <a:off x="3936491" y="3337560"/>
+            <a:off x="3936491" y="3520439"/>
             <a:ext cx="914400" cy="914400"/>
           </a:xfrm>
           <a:prstGeom prst="rect">
@@ -25994,7 +25994,7 @@
         </p:nvSpPr>
         <p:spPr>
           <a:xfrm>
-            <a:off x="4960620" y="3236976"/>
+            <a:off x="4960620" y="3419856"/>
             <a:ext cx="2043684" cy="384048"/>
           </a:xfrm>
           <a:prstGeom prst="rect">
@@ -26033,7 +26033,7 @@
         </p:nvSpPr>
         <p:spPr>
           <a:xfrm>
-            <a:off x="4960620" y="3675887"/>
+            <a:off x="4960620" y="3858768"/>
             <a:ext cx="2043684" cy="694944"/>
           </a:xfrm>
           <a:prstGeom prst="rect">
@@ -26072,7 +26072,7 @@
         </p:nvSpPr>
         <p:spPr>
           <a:xfrm>
-            <a:off x="502920" y="4645152"/>
+            <a:off x="502920" y="4828031"/>
             <a:ext cx="3177540" cy="1298448"/>
           </a:xfrm>
           <a:prstGeom prst="roundRect">
@@ -26127,7 +26127,7 @@
         </p:blipFill>
         <p:spPr>
           <a:xfrm>
-            <a:off x="557784" y="4837176"/>
+            <a:off x="557784" y="5020055"/>
             <a:ext cx="914400" cy="914400"/>
           </a:xfrm>
           <a:prstGeom prst="rect">
@@ -26146,7 +26146,7 @@
         </p:nvSpPr>
         <p:spPr>
           <a:xfrm>
-            <a:off x="1581912" y="4736592"/>
+            <a:off x="1581912" y="4919471"/>
             <a:ext cx="2043684" cy="384048"/>
           </a:xfrm>
           <a:prstGeom prst="rect">
@@ -26185,7 +26185,7 @@
         </p:nvSpPr>
         <p:spPr>
           <a:xfrm>
-            <a:off x="1581912" y="5175504"/>
+            <a:off x="1581912" y="5358383"/>
             <a:ext cx="2043684" cy="694944"/>
           </a:xfrm>
           <a:prstGeom prst="rect">
@@ -26224,7 +26224,7 @@
         </p:nvSpPr>
         <p:spPr>
           <a:xfrm>
-            <a:off x="3881628" y="4645152"/>
+            <a:off x="3881628" y="4828031"/>
             <a:ext cx="3177540" cy="1298448"/>
           </a:xfrm>
           <a:prstGeom prst="roundRect">
@@ -26279,7 +26279,7 @@
         </p:blipFill>
         <p:spPr>
           <a:xfrm>
-            <a:off x="3936491" y="4837176"/>
+            <a:off x="3936491" y="5020055"/>
             <a:ext cx="914400" cy="914400"/>
           </a:xfrm>
           <a:prstGeom prst="rect">
@@ -26298,7 +26298,7 @@
         </p:nvSpPr>
         <p:spPr>
           <a:xfrm>
-            <a:off x="4960620" y="4736592"/>
+            <a:off x="4960620" y="4919471"/>
             <a:ext cx="2043684" cy="384048"/>
           </a:xfrm>
           <a:prstGeom prst="rect">
@@ -26337,7 +26337,7 @@
         </p:nvSpPr>
         <p:spPr>
           <a:xfrm>
-            <a:off x="4960620" y="5175504"/>
+            <a:off x="4960620" y="5358383"/>
             <a:ext cx="2043684" cy="694944"/>
           </a:xfrm>
           <a:prstGeom prst="rect">

</xml_diff>

<commit_message>
P2: change goal numbering from vertical 01/02 to 1./2.
Two-digit numbers wrapped vertically in the narrow badge box; switched to
single-digit '1.'-'6.' format. Regenerated PDF, PPTX and Word outputs.
</commit_message>
<xml_diff>
--- a/mandala_l1_handout.pptx
+++ b/mandala_l1_handout.pptx
@@ -23793,8 +23793,8 @@
         </p:nvSpPr>
         <p:spPr>
           <a:xfrm>
-            <a:off x="630936" y="1207008"/>
-            <a:ext cx="365760" cy="274320"/>
+            <a:off x="649224" y="1207008"/>
+            <a:ext cx="457200" cy="274320"/>
           </a:xfrm>
           <a:prstGeom prst="rect">
             <a:avLst/>
@@ -23813,13 +23813,13 @@
               </a:lnSpc>
             </a:pPr>
             <a:r>
-              <a:rPr sz="1320" b="1" i="0">
+              <a:rPr sz="1560" b="1" i="0">
                 <a:solidFill>
                   <a:srgbClr val="A95C66"/>
                 </a:solidFill>
                 <a:latin typeface="微軟正黑體"/>
               </a:rPr>
-              <a:t>01</a:t>
+              <a:t>1.</a:t>
             </a:r>
           </a:p>
         </p:txBody>
@@ -24044,8 +24044,8 @@
         </p:nvSpPr>
         <p:spPr>
           <a:xfrm>
-            <a:off x="4009644" y="1207008"/>
-            <a:ext cx="365760" cy="274320"/>
+            <a:off x="4027932" y="1207008"/>
+            <a:ext cx="457200" cy="274320"/>
           </a:xfrm>
           <a:prstGeom prst="rect">
             <a:avLst/>
@@ -24064,13 +24064,13 @@
               </a:lnSpc>
             </a:pPr>
             <a:r>
-              <a:rPr sz="1320" b="1" i="0">
+              <a:rPr sz="1560" b="1" i="0">
                 <a:solidFill>
                   <a:srgbClr val="A95C66"/>
                 </a:solidFill>
                 <a:latin typeface="微軟正黑體"/>
               </a:rPr>
-              <a:t>02</a:t>
+              <a:t>2.</a:t>
             </a:r>
           </a:p>
         </p:txBody>
@@ -24295,8 +24295,8 @@
         </p:nvSpPr>
         <p:spPr>
           <a:xfrm>
-            <a:off x="630936" y="2852927"/>
-            <a:ext cx="365760" cy="274320"/>
+            <a:off x="649224" y="2852927"/>
+            <a:ext cx="457200" cy="274320"/>
           </a:xfrm>
           <a:prstGeom prst="rect">
             <a:avLst/>
@@ -24315,13 +24315,13 @@
               </a:lnSpc>
             </a:pPr>
             <a:r>
-              <a:rPr sz="1320" b="1" i="0">
+              <a:rPr sz="1560" b="1" i="0">
                 <a:solidFill>
                   <a:srgbClr val="A95C66"/>
                 </a:solidFill>
                 <a:latin typeface="微軟正黑體"/>
               </a:rPr>
-              <a:t>03</a:t>
+              <a:t>3.</a:t>
             </a:r>
           </a:p>
         </p:txBody>
@@ -24546,8 +24546,8 @@
         </p:nvSpPr>
         <p:spPr>
           <a:xfrm>
-            <a:off x="4009644" y="2852927"/>
-            <a:ext cx="365760" cy="274320"/>
+            <a:off x="4027932" y="2852927"/>
+            <a:ext cx="457200" cy="274320"/>
           </a:xfrm>
           <a:prstGeom prst="rect">
             <a:avLst/>
@@ -24566,13 +24566,13 @@
               </a:lnSpc>
             </a:pPr>
             <a:r>
-              <a:rPr sz="1320" b="1" i="0">
+              <a:rPr sz="1560" b="1" i="0">
                 <a:solidFill>
                   <a:srgbClr val="A95C66"/>
                 </a:solidFill>
                 <a:latin typeface="微軟正黑體"/>
               </a:rPr>
-              <a:t>04</a:t>
+              <a:t>4.</a:t>
             </a:r>
           </a:p>
         </p:txBody>
@@ -24797,8 +24797,8 @@
         </p:nvSpPr>
         <p:spPr>
           <a:xfrm>
-            <a:off x="630936" y="4498848"/>
-            <a:ext cx="365760" cy="274320"/>
+            <a:off x="649224" y="4498848"/>
+            <a:ext cx="457200" cy="274320"/>
           </a:xfrm>
           <a:prstGeom prst="rect">
             <a:avLst/>
@@ -24817,13 +24817,13 @@
               </a:lnSpc>
             </a:pPr>
             <a:r>
-              <a:rPr sz="1320" b="1" i="0">
+              <a:rPr sz="1560" b="1" i="0">
                 <a:solidFill>
                   <a:srgbClr val="A95C66"/>
                 </a:solidFill>
                 <a:latin typeface="微軟正黑體"/>
               </a:rPr>
-              <a:t>05</a:t>
+              <a:t>5.</a:t>
             </a:r>
           </a:p>
         </p:txBody>
@@ -25048,8 +25048,8 @@
         </p:nvSpPr>
         <p:spPr>
           <a:xfrm>
-            <a:off x="4009644" y="4498848"/>
-            <a:ext cx="365760" cy="274320"/>
+            <a:off x="4027932" y="4498848"/>
+            <a:ext cx="457200" cy="274320"/>
           </a:xfrm>
           <a:prstGeom prst="rect">
             <a:avLst/>
@@ -25068,13 +25068,13 @@
               </a:lnSpc>
             </a:pPr>
             <a:r>
-              <a:rPr sz="1320" b="1" i="0">
+              <a:rPr sz="1560" b="1" i="0">
                 <a:solidFill>
                   <a:srgbClr val="A95C66"/>
                 </a:solidFill>
                 <a:latin typeface="微軟正黑體"/>
               </a:rPr>
-              <a:t>06</a:t>
+              <a:t>6.</a:t>
             </a:r>
           </a:p>
         </p:txBody>

</xml_diff>

<commit_message>
Space out grids on P2-P8: larger header gap, rows fill bottom space
P2/P3/P8 spread their cards down into the empty lower area; P5/P6/P7 get a
bigger gap below the header. Full pages (P9, P21-P30) untouched.
Regenerated PDF, PPTX and Word outputs.
</commit_message>
<xml_diff>
--- a/mandala_l1_handout.pptx
+++ b/mandala_l1_handout.pptx
@@ -23659,7 +23659,7 @@
         </p:nvSpPr>
         <p:spPr>
           <a:xfrm>
-            <a:off x="502920" y="1143000"/>
+            <a:off x="502920" y="1691640"/>
             <a:ext cx="3177540" cy="1444752"/>
           </a:xfrm>
           <a:prstGeom prst="roundRect">
@@ -23705,7 +23705,7 @@
         </p:nvSpPr>
         <p:spPr>
           <a:xfrm>
-            <a:off x="502920" y="1143000"/>
+            <a:off x="502920" y="1691640"/>
             <a:ext cx="3177540" cy="384048"/>
           </a:xfrm>
           <a:prstGeom prst="roundRect">
@@ -23749,7 +23749,7 @@
         </p:nvSpPr>
         <p:spPr>
           <a:xfrm>
-            <a:off x="640080" y="1179576"/>
+            <a:off x="640080" y="1728216"/>
             <a:ext cx="3040380" cy="347472"/>
           </a:xfrm>
           <a:prstGeom prst="rect">
@@ -23793,7 +23793,7 @@
         </p:nvSpPr>
         <p:spPr>
           <a:xfrm>
-            <a:off x="649224" y="1207008"/>
+            <a:off x="649224" y="1755648"/>
             <a:ext cx="457200" cy="274320"/>
           </a:xfrm>
           <a:prstGeom prst="rect">
@@ -23832,7 +23832,7 @@
         </p:nvSpPr>
         <p:spPr>
           <a:xfrm>
-            <a:off x="1051560" y="1197864"/>
+            <a:off x="1051560" y="1746504"/>
             <a:ext cx="2491740" cy="310896"/>
           </a:xfrm>
           <a:prstGeom prst="rect">
@@ -23871,7 +23871,7 @@
         </p:nvSpPr>
         <p:spPr>
           <a:xfrm>
-            <a:off x="704088" y="1655064"/>
+            <a:off x="704088" y="2203704"/>
             <a:ext cx="2830068" cy="841248"/>
           </a:xfrm>
           <a:prstGeom prst="rect">
@@ -23910,7 +23910,7 @@
         </p:nvSpPr>
         <p:spPr>
           <a:xfrm>
-            <a:off x="3881628" y="1143000"/>
+            <a:off x="3881628" y="1691640"/>
             <a:ext cx="3177540" cy="1444752"/>
           </a:xfrm>
           <a:prstGeom prst="roundRect">
@@ -23956,7 +23956,7 @@
         </p:nvSpPr>
         <p:spPr>
           <a:xfrm>
-            <a:off x="3881628" y="1143000"/>
+            <a:off x="3881628" y="1691640"/>
             <a:ext cx="3177540" cy="384048"/>
           </a:xfrm>
           <a:prstGeom prst="roundRect">
@@ -24000,7 +24000,7 @@
         </p:nvSpPr>
         <p:spPr>
           <a:xfrm>
-            <a:off x="4018788" y="1179576"/>
+            <a:off x="4018788" y="1728216"/>
             <a:ext cx="3040380" cy="347472"/>
           </a:xfrm>
           <a:prstGeom prst="rect">
@@ -24044,7 +24044,7 @@
         </p:nvSpPr>
         <p:spPr>
           <a:xfrm>
-            <a:off x="4027932" y="1207008"/>
+            <a:off x="4027932" y="1755648"/>
             <a:ext cx="457200" cy="274320"/>
           </a:xfrm>
           <a:prstGeom prst="rect">
@@ -24083,7 +24083,7 @@
         </p:nvSpPr>
         <p:spPr>
           <a:xfrm>
-            <a:off x="4430268" y="1197864"/>
+            <a:off x="4430268" y="1746504"/>
             <a:ext cx="2491740" cy="310896"/>
           </a:xfrm>
           <a:prstGeom prst="rect">
@@ -24122,7 +24122,7 @@
         </p:nvSpPr>
         <p:spPr>
           <a:xfrm>
-            <a:off x="4082796" y="1655064"/>
+            <a:off x="4082796" y="2203704"/>
             <a:ext cx="2830068" cy="841248"/>
           </a:xfrm>
           <a:prstGeom prst="rect">
@@ -24161,7 +24161,7 @@
         </p:nvSpPr>
         <p:spPr>
           <a:xfrm>
-            <a:off x="502920" y="2788920"/>
+            <a:off x="502920" y="3849624"/>
             <a:ext cx="3177540" cy="1444752"/>
           </a:xfrm>
           <a:prstGeom prst="roundRect">
@@ -24207,7 +24207,7 @@
         </p:nvSpPr>
         <p:spPr>
           <a:xfrm>
-            <a:off x="502920" y="2788920"/>
+            <a:off x="502920" y="3849624"/>
             <a:ext cx="3177540" cy="384048"/>
           </a:xfrm>
           <a:prstGeom prst="roundRect">
@@ -24251,7 +24251,7 @@
         </p:nvSpPr>
         <p:spPr>
           <a:xfrm>
-            <a:off x="640080" y="2825496"/>
+            <a:off x="640080" y="3886200"/>
             <a:ext cx="3040380" cy="347472"/>
           </a:xfrm>
           <a:prstGeom prst="rect">
@@ -24295,7 +24295,7 @@
         </p:nvSpPr>
         <p:spPr>
           <a:xfrm>
-            <a:off x="649224" y="2852927"/>
+            <a:off x="649224" y="3913632"/>
             <a:ext cx="457200" cy="274320"/>
           </a:xfrm>
           <a:prstGeom prst="rect">
@@ -24334,7 +24334,7 @@
         </p:nvSpPr>
         <p:spPr>
           <a:xfrm>
-            <a:off x="1051560" y="2843784"/>
+            <a:off x="1051560" y="3904488"/>
             <a:ext cx="2491740" cy="310896"/>
           </a:xfrm>
           <a:prstGeom prst="rect">
@@ -24373,7 +24373,7 @@
         </p:nvSpPr>
         <p:spPr>
           <a:xfrm>
-            <a:off x="704088" y="3300984"/>
+            <a:off x="704088" y="4361688"/>
             <a:ext cx="2830068" cy="841248"/>
           </a:xfrm>
           <a:prstGeom prst="rect">
@@ -24412,7 +24412,7 @@
         </p:nvSpPr>
         <p:spPr>
           <a:xfrm>
-            <a:off x="3881628" y="2788920"/>
+            <a:off x="3881628" y="3849624"/>
             <a:ext cx="3177540" cy="1444752"/>
           </a:xfrm>
           <a:prstGeom prst="roundRect">
@@ -24458,7 +24458,7 @@
         </p:nvSpPr>
         <p:spPr>
           <a:xfrm>
-            <a:off x="3881628" y="2788920"/>
+            <a:off x="3881628" y="3849624"/>
             <a:ext cx="3177540" cy="384048"/>
           </a:xfrm>
           <a:prstGeom prst="roundRect">
@@ -24502,7 +24502,7 @@
         </p:nvSpPr>
         <p:spPr>
           <a:xfrm>
-            <a:off x="4018788" y="2825496"/>
+            <a:off x="4018788" y="3886200"/>
             <a:ext cx="3040380" cy="347472"/>
           </a:xfrm>
           <a:prstGeom prst="rect">
@@ -24546,7 +24546,7 @@
         </p:nvSpPr>
         <p:spPr>
           <a:xfrm>
-            <a:off x="4027932" y="2852927"/>
+            <a:off x="4027932" y="3913632"/>
             <a:ext cx="457200" cy="274320"/>
           </a:xfrm>
           <a:prstGeom prst="rect">
@@ -24585,7 +24585,7 @@
         </p:nvSpPr>
         <p:spPr>
           <a:xfrm>
-            <a:off x="4430268" y="2843784"/>
+            <a:off x="4430268" y="3904488"/>
             <a:ext cx="2491740" cy="310896"/>
           </a:xfrm>
           <a:prstGeom prst="rect">
@@ -24624,7 +24624,7 @@
         </p:nvSpPr>
         <p:spPr>
           <a:xfrm>
-            <a:off x="4082796" y="3300984"/>
+            <a:off x="4082796" y="4361688"/>
             <a:ext cx="2830068" cy="841248"/>
           </a:xfrm>
           <a:prstGeom prst="rect">
@@ -24663,7 +24663,7 @@
         </p:nvSpPr>
         <p:spPr>
           <a:xfrm>
-            <a:off x="502920" y="4434840"/>
+            <a:off x="502920" y="6007608"/>
             <a:ext cx="3177540" cy="1444752"/>
           </a:xfrm>
           <a:prstGeom prst="roundRect">
@@ -24709,7 +24709,7 @@
         </p:nvSpPr>
         <p:spPr>
           <a:xfrm>
-            <a:off x="502920" y="4434840"/>
+            <a:off x="502920" y="6007608"/>
             <a:ext cx="3177540" cy="384048"/>
           </a:xfrm>
           <a:prstGeom prst="roundRect">
@@ -24753,7 +24753,7 @@
         </p:nvSpPr>
         <p:spPr>
           <a:xfrm>
-            <a:off x="640080" y="4471416"/>
+            <a:off x="640080" y="6044184"/>
             <a:ext cx="3040380" cy="347472"/>
           </a:xfrm>
           <a:prstGeom prst="rect">
@@ -24797,7 +24797,7 @@
         </p:nvSpPr>
         <p:spPr>
           <a:xfrm>
-            <a:off x="649224" y="4498848"/>
+            <a:off x="649224" y="6071616"/>
             <a:ext cx="457200" cy="274320"/>
           </a:xfrm>
           <a:prstGeom prst="rect">
@@ -24836,7 +24836,7 @@
         </p:nvSpPr>
         <p:spPr>
           <a:xfrm>
-            <a:off x="1051560" y="4489703"/>
+            <a:off x="1051560" y="6062472"/>
             <a:ext cx="2491740" cy="310896"/>
           </a:xfrm>
           <a:prstGeom prst="rect">
@@ -24875,7 +24875,7 @@
         </p:nvSpPr>
         <p:spPr>
           <a:xfrm>
-            <a:off x="704088" y="4946904"/>
+            <a:off x="704088" y="6519672"/>
             <a:ext cx="2830068" cy="841248"/>
           </a:xfrm>
           <a:prstGeom prst="rect">
@@ -24914,7 +24914,7 @@
         </p:nvSpPr>
         <p:spPr>
           <a:xfrm>
-            <a:off x="3881628" y="4434840"/>
+            <a:off x="3881628" y="6007608"/>
             <a:ext cx="3177540" cy="1444752"/>
           </a:xfrm>
           <a:prstGeom prst="roundRect">
@@ -24960,7 +24960,7 @@
         </p:nvSpPr>
         <p:spPr>
           <a:xfrm>
-            <a:off x="3881628" y="4434840"/>
+            <a:off x="3881628" y="6007608"/>
             <a:ext cx="3177540" cy="384048"/>
           </a:xfrm>
           <a:prstGeom prst="roundRect">
@@ -25004,7 +25004,7 @@
         </p:nvSpPr>
         <p:spPr>
           <a:xfrm>
-            <a:off x="4018788" y="4471416"/>
+            <a:off x="4018788" y="6044184"/>
             <a:ext cx="3040380" cy="347472"/>
           </a:xfrm>
           <a:prstGeom prst="rect">
@@ -25048,7 +25048,7 @@
         </p:nvSpPr>
         <p:spPr>
           <a:xfrm>
-            <a:off x="4027932" y="4498848"/>
+            <a:off x="4027932" y="6071616"/>
             <a:ext cx="457200" cy="274320"/>
           </a:xfrm>
           <a:prstGeom prst="rect">
@@ -25087,7 +25087,7 @@
         </p:nvSpPr>
         <p:spPr>
           <a:xfrm>
-            <a:off x="4430268" y="4489703"/>
+            <a:off x="4430268" y="6062472"/>
             <a:ext cx="2491740" cy="310896"/>
           </a:xfrm>
           <a:prstGeom prst="rect">
@@ -25126,7 +25126,7 @@
         </p:nvSpPr>
         <p:spPr>
           <a:xfrm>
-            <a:off x="4082796" y="4946904"/>
+            <a:off x="4082796" y="6519672"/>
             <a:ext cx="2830068" cy="841248"/>
           </a:xfrm>
           <a:prstGeom prst="rect">
@@ -40636,8 +40636,8 @@
         </p:nvSpPr>
         <p:spPr>
           <a:xfrm>
-            <a:off x="502920" y="1143000"/>
-            <a:ext cx="3177540" cy="1115568"/>
+            <a:off x="502920" y="1691640"/>
+            <a:ext cx="3177540" cy="1280160"/>
           </a:xfrm>
           <a:prstGeom prst="roundRect">
             <a:avLst/>
@@ -40682,8 +40682,8 @@
         </p:nvSpPr>
         <p:spPr>
           <a:xfrm>
-            <a:off x="502920" y="1143000"/>
-            <a:ext cx="91440" cy="1115568"/>
+            <a:off x="502920" y="1691640"/>
+            <a:ext cx="91440" cy="1280160"/>
           </a:xfrm>
           <a:prstGeom prst="rect">
             <a:avLst/>
@@ -40726,7 +40726,7 @@
         </p:nvSpPr>
         <p:spPr>
           <a:xfrm>
-            <a:off x="740664" y="1252728"/>
+            <a:off x="740664" y="1801368"/>
             <a:ext cx="2811780" cy="438912"/>
           </a:xfrm>
           <a:prstGeom prst="rect">
@@ -40765,7 +40765,7 @@
         </p:nvSpPr>
         <p:spPr>
           <a:xfrm>
-            <a:off x="758952" y="1728216"/>
+            <a:off x="758952" y="2276856"/>
             <a:ext cx="2793492" cy="438912"/>
           </a:xfrm>
           <a:prstGeom prst="rect">
@@ -40804,8 +40804,8 @@
         </p:nvSpPr>
         <p:spPr>
           <a:xfrm>
-            <a:off x="3881628" y="1143000"/>
-            <a:ext cx="3177540" cy="1115568"/>
+            <a:off x="3881628" y="1691640"/>
+            <a:ext cx="3177540" cy="1280160"/>
           </a:xfrm>
           <a:prstGeom prst="roundRect">
             <a:avLst/>
@@ -40850,8 +40850,8 @@
         </p:nvSpPr>
         <p:spPr>
           <a:xfrm>
-            <a:off x="3881628" y="1143000"/>
-            <a:ext cx="91440" cy="1115568"/>
+            <a:off x="3881628" y="1691640"/>
+            <a:ext cx="91440" cy="1280160"/>
           </a:xfrm>
           <a:prstGeom prst="rect">
             <a:avLst/>
@@ -40894,7 +40894,7 @@
         </p:nvSpPr>
         <p:spPr>
           <a:xfrm>
-            <a:off x="4119372" y="1252728"/>
+            <a:off x="4119372" y="1801368"/>
             <a:ext cx="2811780" cy="438912"/>
           </a:xfrm>
           <a:prstGeom prst="rect">
@@ -40933,7 +40933,7 @@
         </p:nvSpPr>
         <p:spPr>
           <a:xfrm>
-            <a:off x="4137660" y="1728216"/>
+            <a:off x="4137660" y="2276856"/>
             <a:ext cx="2793492" cy="438912"/>
           </a:xfrm>
           <a:prstGeom prst="rect">
@@ -40972,8 +40972,8 @@
         </p:nvSpPr>
         <p:spPr>
           <a:xfrm>
-            <a:off x="502920" y="2459736"/>
-            <a:ext cx="3177540" cy="1115568"/>
+            <a:off x="502920" y="3840479"/>
+            <a:ext cx="3177540" cy="1280160"/>
           </a:xfrm>
           <a:prstGeom prst="roundRect">
             <a:avLst/>
@@ -41018,8 +41018,8 @@
         </p:nvSpPr>
         <p:spPr>
           <a:xfrm>
-            <a:off x="502920" y="2459736"/>
-            <a:ext cx="91440" cy="1115568"/>
+            <a:off x="502920" y="3840479"/>
+            <a:ext cx="91440" cy="1280160"/>
           </a:xfrm>
           <a:prstGeom prst="rect">
             <a:avLst/>
@@ -41062,7 +41062,7 @@
         </p:nvSpPr>
         <p:spPr>
           <a:xfrm>
-            <a:off x="740664" y="2569464"/>
+            <a:off x="740664" y="3950207"/>
             <a:ext cx="2811780" cy="438912"/>
           </a:xfrm>
           <a:prstGeom prst="rect">
@@ -41101,7 +41101,7 @@
         </p:nvSpPr>
         <p:spPr>
           <a:xfrm>
-            <a:off x="758952" y="3044952"/>
+            <a:off x="758952" y="4425695"/>
             <a:ext cx="2793492" cy="438912"/>
           </a:xfrm>
           <a:prstGeom prst="rect">
@@ -41140,8 +41140,8 @@
         </p:nvSpPr>
         <p:spPr>
           <a:xfrm>
-            <a:off x="3881628" y="2459736"/>
-            <a:ext cx="3177540" cy="1115568"/>
+            <a:off x="3881628" y="3840479"/>
+            <a:ext cx="3177540" cy="1280160"/>
           </a:xfrm>
           <a:prstGeom prst="roundRect">
             <a:avLst/>
@@ -41186,8 +41186,8 @@
         </p:nvSpPr>
         <p:spPr>
           <a:xfrm>
-            <a:off x="3881628" y="2459736"/>
-            <a:ext cx="91440" cy="1115568"/>
+            <a:off x="3881628" y="3840479"/>
+            <a:ext cx="91440" cy="1280160"/>
           </a:xfrm>
           <a:prstGeom prst="rect">
             <a:avLst/>
@@ -41230,7 +41230,7 @@
         </p:nvSpPr>
         <p:spPr>
           <a:xfrm>
-            <a:off x="4119372" y="2569464"/>
+            <a:off x="4119372" y="3950207"/>
             <a:ext cx="2811780" cy="438912"/>
           </a:xfrm>
           <a:prstGeom prst="rect">
@@ -41269,7 +41269,7 @@
         </p:nvSpPr>
         <p:spPr>
           <a:xfrm>
-            <a:off x="4137660" y="3044952"/>
+            <a:off x="4137660" y="4425695"/>
             <a:ext cx="2793492" cy="438912"/>
           </a:xfrm>
           <a:prstGeom prst="rect">
@@ -41308,8 +41308,8 @@
         </p:nvSpPr>
         <p:spPr>
           <a:xfrm>
-            <a:off x="502920" y="3776472"/>
-            <a:ext cx="3177540" cy="1115568"/>
+            <a:off x="502920" y="5989319"/>
+            <a:ext cx="3177540" cy="1280160"/>
           </a:xfrm>
           <a:prstGeom prst="roundRect">
             <a:avLst/>
@@ -41354,8 +41354,8 @@
         </p:nvSpPr>
         <p:spPr>
           <a:xfrm>
-            <a:off x="502920" y="3776472"/>
-            <a:ext cx="91440" cy="1115568"/>
+            <a:off x="502920" y="5989319"/>
+            <a:ext cx="91440" cy="1280160"/>
           </a:xfrm>
           <a:prstGeom prst="rect">
             <a:avLst/>
@@ -41398,7 +41398,7 @@
         </p:nvSpPr>
         <p:spPr>
           <a:xfrm>
-            <a:off x="740664" y="3886200"/>
+            <a:off x="740664" y="6099047"/>
             <a:ext cx="2811780" cy="438912"/>
           </a:xfrm>
           <a:prstGeom prst="rect">
@@ -41437,7 +41437,7 @@
         </p:nvSpPr>
         <p:spPr>
           <a:xfrm>
-            <a:off x="758952" y="4361688"/>
+            <a:off x="758952" y="6574535"/>
             <a:ext cx="2793492" cy="438912"/>
           </a:xfrm>
           <a:prstGeom prst="rect">
@@ -45976,7 +45976,7 @@
         </p:nvSpPr>
         <p:spPr>
           <a:xfrm>
-            <a:off x="502920" y="1216152"/>
+            <a:off x="502920" y="1490472"/>
             <a:ext cx="109728" cy="109728"/>
           </a:xfrm>
           <a:prstGeom prst="ellipse">
@@ -46020,7 +46020,7 @@
         </p:nvSpPr>
         <p:spPr>
           <a:xfrm>
-            <a:off x="758952" y="1124712"/>
+            <a:off x="758952" y="1399032"/>
             <a:ext cx="6281928" cy="347472"/>
           </a:xfrm>
           <a:prstGeom prst="rect">
@@ -46059,7 +46059,7 @@
         </p:nvSpPr>
         <p:spPr>
           <a:xfrm>
-            <a:off x="777240" y="1490472"/>
+            <a:off x="777240" y="1764792"/>
             <a:ext cx="6263640" cy="548640"/>
           </a:xfrm>
           <a:prstGeom prst="rect">
@@ -46098,7 +46098,7 @@
         </p:nvSpPr>
         <p:spPr>
           <a:xfrm>
-            <a:off x="502920" y="2221992"/>
+            <a:off x="502920" y="2423160"/>
             <a:ext cx="109728" cy="109728"/>
           </a:xfrm>
           <a:prstGeom prst="ellipse">
@@ -46142,7 +46142,7 @@
         </p:nvSpPr>
         <p:spPr>
           <a:xfrm>
-            <a:off x="758952" y="2130552"/>
+            <a:off x="758952" y="2331720"/>
             <a:ext cx="6281928" cy="347472"/>
           </a:xfrm>
           <a:prstGeom prst="rect">
@@ -46181,7 +46181,7 @@
         </p:nvSpPr>
         <p:spPr>
           <a:xfrm>
-            <a:off x="777240" y="2496312"/>
+            <a:off x="777240" y="2697480"/>
             <a:ext cx="6263640" cy="548640"/>
           </a:xfrm>
           <a:prstGeom prst="rect">
@@ -46220,7 +46220,7 @@
         </p:nvSpPr>
         <p:spPr>
           <a:xfrm>
-            <a:off x="502920" y="3227832"/>
+            <a:off x="502920" y="3355848"/>
             <a:ext cx="109728" cy="109728"/>
           </a:xfrm>
           <a:prstGeom prst="ellipse">
@@ -46264,7 +46264,7 @@
         </p:nvSpPr>
         <p:spPr>
           <a:xfrm>
-            <a:off x="758952" y="3136392"/>
+            <a:off x="758952" y="3264408"/>
             <a:ext cx="6281928" cy="347472"/>
           </a:xfrm>
           <a:prstGeom prst="rect">
@@ -46303,7 +46303,7 @@
         </p:nvSpPr>
         <p:spPr>
           <a:xfrm>
-            <a:off x="777240" y="3502152"/>
+            <a:off x="777240" y="3630168"/>
             <a:ext cx="6263640" cy="548640"/>
           </a:xfrm>
           <a:prstGeom prst="rect">
@@ -46342,7 +46342,7 @@
         </p:nvSpPr>
         <p:spPr>
           <a:xfrm>
-            <a:off x="502920" y="4233672"/>
+            <a:off x="502920" y="4288536"/>
             <a:ext cx="109728" cy="109728"/>
           </a:xfrm>
           <a:prstGeom prst="ellipse">
@@ -46386,7 +46386,7 @@
         </p:nvSpPr>
         <p:spPr>
           <a:xfrm>
-            <a:off x="758952" y="4142232"/>
+            <a:off x="758952" y="4197096"/>
             <a:ext cx="6281928" cy="347472"/>
           </a:xfrm>
           <a:prstGeom prst="rect">
@@ -46425,7 +46425,7 @@
         </p:nvSpPr>
         <p:spPr>
           <a:xfrm>
-            <a:off x="777240" y="4507992"/>
+            <a:off x="777240" y="4562856"/>
             <a:ext cx="6263640" cy="548640"/>
           </a:xfrm>
           <a:prstGeom prst="rect">
@@ -47783,7 +47783,7 @@
         </p:nvSpPr>
         <p:spPr>
           <a:xfrm>
-            <a:off x="502920" y="1115568"/>
+            <a:off x="502920" y="1280160"/>
             <a:ext cx="6556248" cy="1572768"/>
           </a:xfrm>
           <a:prstGeom prst="roundRect">
@@ -47829,7 +47829,7 @@
         </p:nvSpPr>
         <p:spPr>
           <a:xfrm>
-            <a:off x="667512" y="1664207"/>
+            <a:off x="667512" y="1828800"/>
             <a:ext cx="438912" cy="438912"/>
           </a:xfrm>
           <a:prstGeom prst="ellipse">
@@ -47875,7 +47875,7 @@
         </p:nvSpPr>
         <p:spPr>
           <a:xfrm>
-            <a:off x="1197864" y="1664207"/>
+            <a:off x="1197864" y="1828800"/>
             <a:ext cx="438912" cy="438912"/>
           </a:xfrm>
           <a:prstGeom prst="ellipse">
@@ -47921,7 +47921,7 @@
         </p:nvSpPr>
         <p:spPr>
           <a:xfrm>
-            <a:off x="1728216" y="1664207"/>
+            <a:off x="1728216" y="1828800"/>
             <a:ext cx="438912" cy="438912"/>
           </a:xfrm>
           <a:prstGeom prst="ellipse">
@@ -47967,7 +47967,7 @@
         </p:nvSpPr>
         <p:spPr>
           <a:xfrm>
-            <a:off x="704088" y="1207008"/>
+            <a:off x="704088" y="1371600"/>
             <a:ext cx="2377440" cy="384048"/>
           </a:xfrm>
           <a:prstGeom prst="rect">
@@ -48006,7 +48006,7 @@
         </p:nvSpPr>
         <p:spPr>
           <a:xfrm>
-            <a:off x="3172968" y="1225295"/>
+            <a:off x="3172968" y="1389888"/>
             <a:ext cx="3721608" cy="329184"/>
           </a:xfrm>
           <a:prstGeom prst="rect">
@@ -48045,7 +48045,7 @@
         </p:nvSpPr>
         <p:spPr>
           <a:xfrm>
-            <a:off x="2606039" y="1618488"/>
+            <a:off x="2606039" y="1783080"/>
             <a:ext cx="4270248" cy="987552"/>
           </a:xfrm>
           <a:prstGeom prst="rect">
@@ -48084,7 +48084,7 @@
         </p:nvSpPr>
         <p:spPr>
           <a:xfrm>
-            <a:off x="704088" y="2350008"/>
+            <a:off x="704088" y="2514600"/>
             <a:ext cx="2011680" cy="274320"/>
           </a:xfrm>
           <a:prstGeom prst="rect">
@@ -48123,7 +48123,7 @@
         </p:nvSpPr>
         <p:spPr>
           <a:xfrm>
-            <a:off x="502920" y="2871215"/>
+            <a:off x="502920" y="3072384"/>
             <a:ext cx="6556248" cy="1572768"/>
           </a:xfrm>
           <a:prstGeom prst="roundRect">
@@ -48169,7 +48169,7 @@
         </p:nvSpPr>
         <p:spPr>
           <a:xfrm>
-            <a:off x="667512" y="3419856"/>
+            <a:off x="667512" y="3621024"/>
             <a:ext cx="438912" cy="438912"/>
           </a:xfrm>
           <a:prstGeom prst="ellipse">
@@ -48215,7 +48215,7 @@
         </p:nvSpPr>
         <p:spPr>
           <a:xfrm>
-            <a:off x="1197864" y="3419856"/>
+            <a:off x="1197864" y="3621024"/>
             <a:ext cx="438912" cy="438912"/>
           </a:xfrm>
           <a:prstGeom prst="ellipse">
@@ -48261,7 +48261,7 @@
         </p:nvSpPr>
         <p:spPr>
           <a:xfrm>
-            <a:off x="1728216" y="3419856"/>
+            <a:off x="1728216" y="3621024"/>
             <a:ext cx="438912" cy="438912"/>
           </a:xfrm>
           <a:prstGeom prst="ellipse">
@@ -48307,7 +48307,7 @@
         </p:nvSpPr>
         <p:spPr>
           <a:xfrm>
-            <a:off x="704088" y="2962656"/>
+            <a:off x="704088" y="3163824"/>
             <a:ext cx="2377440" cy="384048"/>
           </a:xfrm>
           <a:prstGeom prst="rect">
@@ -48346,7 +48346,7 @@
         </p:nvSpPr>
         <p:spPr>
           <a:xfrm>
-            <a:off x="3172968" y="2980944"/>
+            <a:off x="3172968" y="3182112"/>
             <a:ext cx="3721608" cy="329184"/>
           </a:xfrm>
           <a:prstGeom prst="rect">
@@ -48385,7 +48385,7 @@
         </p:nvSpPr>
         <p:spPr>
           <a:xfrm>
-            <a:off x="2606039" y="3374135"/>
+            <a:off x="2606039" y="3575304"/>
             <a:ext cx="4270248" cy="987552"/>
           </a:xfrm>
           <a:prstGeom prst="rect">
@@ -48424,7 +48424,7 @@
         </p:nvSpPr>
         <p:spPr>
           <a:xfrm>
-            <a:off x="704088" y="4105656"/>
+            <a:off x="704088" y="4306824"/>
             <a:ext cx="2011680" cy="274320"/>
           </a:xfrm>
           <a:prstGeom prst="rect">
@@ -48463,7 +48463,7 @@
         </p:nvSpPr>
         <p:spPr>
           <a:xfrm>
-            <a:off x="502920" y="4626864"/>
+            <a:off x="502920" y="4864608"/>
             <a:ext cx="6556248" cy="1572768"/>
           </a:xfrm>
           <a:prstGeom prst="roundRect">
@@ -48509,7 +48509,7 @@
         </p:nvSpPr>
         <p:spPr>
           <a:xfrm>
-            <a:off x="667512" y="5175503"/>
+            <a:off x="667512" y="5413248"/>
             <a:ext cx="438912" cy="438912"/>
           </a:xfrm>
           <a:prstGeom prst="ellipse">
@@ -48555,7 +48555,7 @@
         </p:nvSpPr>
         <p:spPr>
           <a:xfrm>
-            <a:off x="1197864" y="5175503"/>
+            <a:off x="1197864" y="5413248"/>
             <a:ext cx="438912" cy="438912"/>
           </a:xfrm>
           <a:prstGeom prst="ellipse">
@@ -48601,7 +48601,7 @@
         </p:nvSpPr>
         <p:spPr>
           <a:xfrm>
-            <a:off x="704088" y="4718303"/>
+            <a:off x="704088" y="4956048"/>
             <a:ext cx="2377440" cy="384048"/>
           </a:xfrm>
           <a:prstGeom prst="rect">
@@ -48640,7 +48640,7 @@
         </p:nvSpPr>
         <p:spPr>
           <a:xfrm>
-            <a:off x="3172968" y="4736592"/>
+            <a:off x="3172968" y="4974336"/>
             <a:ext cx="3721608" cy="329184"/>
           </a:xfrm>
           <a:prstGeom prst="rect">
@@ -48679,7 +48679,7 @@
         </p:nvSpPr>
         <p:spPr>
           <a:xfrm>
-            <a:off x="2606039" y="5129783"/>
+            <a:off x="2606039" y="5367528"/>
             <a:ext cx="4270248" cy="987552"/>
           </a:xfrm>
           <a:prstGeom prst="rect">
@@ -48718,7 +48718,7 @@
         </p:nvSpPr>
         <p:spPr>
           <a:xfrm>
-            <a:off x="704088" y="5861304"/>
+            <a:off x="704088" y="6099048"/>
             <a:ext cx="2011680" cy="274320"/>
           </a:xfrm>
           <a:prstGeom prst="rect">
@@ -48757,7 +48757,7 @@
         </p:nvSpPr>
         <p:spPr>
           <a:xfrm>
-            <a:off x="502920" y="6382512"/>
+            <a:off x="502920" y="6656831"/>
             <a:ext cx="6556248" cy="1572768"/>
           </a:xfrm>
           <a:prstGeom prst="roundRect">
@@ -48803,7 +48803,7 @@
         </p:nvSpPr>
         <p:spPr>
           <a:xfrm>
-            <a:off x="667512" y="6931151"/>
+            <a:off x="667512" y="7205471"/>
             <a:ext cx="438912" cy="438912"/>
           </a:xfrm>
           <a:prstGeom prst="ellipse">
@@ -48849,7 +48849,7 @@
         </p:nvSpPr>
         <p:spPr>
           <a:xfrm>
-            <a:off x="1197864" y="6931151"/>
+            <a:off x="1197864" y="7205471"/>
             <a:ext cx="438912" cy="438912"/>
           </a:xfrm>
           <a:prstGeom prst="ellipse">
@@ -48895,7 +48895,7 @@
         </p:nvSpPr>
         <p:spPr>
           <a:xfrm>
-            <a:off x="1728216" y="6931151"/>
+            <a:off x="1728216" y="7205471"/>
             <a:ext cx="438912" cy="438912"/>
           </a:xfrm>
           <a:prstGeom prst="ellipse">
@@ -48941,7 +48941,7 @@
         </p:nvSpPr>
         <p:spPr>
           <a:xfrm>
-            <a:off x="704088" y="6473951"/>
+            <a:off x="704088" y="6748271"/>
             <a:ext cx="2377440" cy="384048"/>
           </a:xfrm>
           <a:prstGeom prst="rect">
@@ -48980,7 +48980,7 @@
         </p:nvSpPr>
         <p:spPr>
           <a:xfrm>
-            <a:off x="3172968" y="6492240"/>
+            <a:off x="3172968" y="6766559"/>
             <a:ext cx="3721608" cy="329184"/>
           </a:xfrm>
           <a:prstGeom prst="rect">
@@ -49019,7 +49019,7 @@
         </p:nvSpPr>
         <p:spPr>
           <a:xfrm>
-            <a:off x="2606039" y="6885431"/>
+            <a:off x="2606039" y="7159751"/>
             <a:ext cx="4270248" cy="987552"/>
           </a:xfrm>
           <a:prstGeom prst="rect">
@@ -49058,7 +49058,7 @@
         </p:nvSpPr>
         <p:spPr>
           <a:xfrm>
-            <a:off x="704088" y="7616952"/>
+            <a:off x="704088" y="7891271"/>
             <a:ext cx="2011680" cy="274320"/>
           </a:xfrm>
           <a:prstGeom prst="rect">
@@ -49097,7 +49097,7 @@
         </p:nvSpPr>
         <p:spPr>
           <a:xfrm>
-            <a:off x="502920" y="8138160"/>
+            <a:off x="502920" y="8449056"/>
             <a:ext cx="6556248" cy="1572768"/>
           </a:xfrm>
           <a:prstGeom prst="roundRect">
@@ -49143,7 +49143,7 @@
         </p:nvSpPr>
         <p:spPr>
           <a:xfrm>
-            <a:off x="667512" y="8686800"/>
+            <a:off x="667512" y="8997696"/>
             <a:ext cx="438912" cy="438912"/>
           </a:xfrm>
           <a:prstGeom prst="ellipse">
@@ -49189,7 +49189,7 @@
         </p:nvSpPr>
         <p:spPr>
           <a:xfrm>
-            <a:off x="1197864" y="8686800"/>
+            <a:off x="1197864" y="8997696"/>
             <a:ext cx="438912" cy="438912"/>
           </a:xfrm>
           <a:prstGeom prst="ellipse">
@@ -49235,7 +49235,7 @@
         </p:nvSpPr>
         <p:spPr>
           <a:xfrm>
-            <a:off x="1728216" y="8686800"/>
+            <a:off x="1728216" y="8997696"/>
             <a:ext cx="438912" cy="438912"/>
           </a:xfrm>
           <a:prstGeom prst="ellipse">
@@ -49281,7 +49281,7 @@
         </p:nvSpPr>
         <p:spPr>
           <a:xfrm>
-            <a:off x="704088" y="8229600"/>
+            <a:off x="704088" y="8540496"/>
             <a:ext cx="2377440" cy="384048"/>
           </a:xfrm>
           <a:prstGeom prst="rect">
@@ -49320,7 +49320,7 @@
         </p:nvSpPr>
         <p:spPr>
           <a:xfrm>
-            <a:off x="3172968" y="8247888"/>
+            <a:off x="3172968" y="8558784"/>
             <a:ext cx="3721608" cy="329184"/>
           </a:xfrm>
           <a:prstGeom prst="rect">
@@ -49359,7 +49359,7 @@
         </p:nvSpPr>
         <p:spPr>
           <a:xfrm>
-            <a:off x="2606039" y="8641080"/>
+            <a:off x="2606039" y="8951976"/>
             <a:ext cx="4270248" cy="987552"/>
           </a:xfrm>
           <a:prstGeom prst="rect">
@@ -49398,7 +49398,7 @@
         </p:nvSpPr>
         <p:spPr>
           <a:xfrm>
-            <a:off x="704088" y="9372600"/>
+            <a:off x="704088" y="9683496"/>
             <a:ext cx="2011680" cy="274320"/>
           </a:xfrm>
           <a:prstGeom prst="rect">
@@ -49697,7 +49697,7 @@
         </p:nvSpPr>
         <p:spPr>
           <a:xfrm>
-            <a:off x="502920" y="1115568"/>
+            <a:off x="502920" y="1298448"/>
             <a:ext cx="6556248" cy="1234440"/>
           </a:xfrm>
           <a:prstGeom prst="roundRect">
@@ -49743,7 +49743,7 @@
         </p:nvSpPr>
         <p:spPr>
           <a:xfrm>
-            <a:off x="502920" y="1115568"/>
+            <a:off x="502920" y="1298448"/>
             <a:ext cx="91440" cy="1234440"/>
           </a:xfrm>
           <a:prstGeom prst="rect">
@@ -49787,7 +49787,7 @@
         </p:nvSpPr>
         <p:spPr>
           <a:xfrm>
-            <a:off x="758952" y="1243584"/>
+            <a:off x="758952" y="1426464"/>
             <a:ext cx="1920240" cy="411480"/>
           </a:xfrm>
           <a:prstGeom prst="rect">
@@ -49826,7 +49826,7 @@
         </p:nvSpPr>
         <p:spPr>
           <a:xfrm>
-            <a:off x="2743200" y="1152144"/>
+            <a:off x="2743200" y="1335024"/>
             <a:ext cx="4178808" cy="1234440"/>
           </a:xfrm>
           <a:prstGeom prst="rect">
@@ -49865,7 +49865,7 @@
         </p:nvSpPr>
         <p:spPr>
           <a:xfrm>
-            <a:off x="502920" y="2551176"/>
+            <a:off x="502920" y="2807208"/>
             <a:ext cx="6556248" cy="1234440"/>
           </a:xfrm>
           <a:prstGeom prst="roundRect">
@@ -49911,7 +49911,7 @@
         </p:nvSpPr>
         <p:spPr>
           <a:xfrm>
-            <a:off x="502920" y="2551176"/>
+            <a:off x="502920" y="2807208"/>
             <a:ext cx="91440" cy="1234440"/>
           </a:xfrm>
           <a:prstGeom prst="rect">
@@ -49955,7 +49955,7 @@
         </p:nvSpPr>
         <p:spPr>
           <a:xfrm>
-            <a:off x="758952" y="2679192"/>
+            <a:off x="758952" y="2935224"/>
             <a:ext cx="1920240" cy="411480"/>
           </a:xfrm>
           <a:prstGeom prst="rect">
@@ -49994,7 +49994,7 @@
         </p:nvSpPr>
         <p:spPr>
           <a:xfrm>
-            <a:off x="2743200" y="2587752"/>
+            <a:off x="2743200" y="2843784"/>
             <a:ext cx="4178808" cy="1234440"/>
           </a:xfrm>
           <a:prstGeom prst="rect">
@@ -50033,7 +50033,7 @@
         </p:nvSpPr>
         <p:spPr>
           <a:xfrm>
-            <a:off x="502920" y="3986784"/>
+            <a:off x="502920" y="4315968"/>
             <a:ext cx="6556248" cy="1234440"/>
           </a:xfrm>
           <a:prstGeom prst="roundRect">
@@ -50079,7 +50079,7 @@
         </p:nvSpPr>
         <p:spPr>
           <a:xfrm>
-            <a:off x="502920" y="3986784"/>
+            <a:off x="502920" y="4315968"/>
             <a:ext cx="91440" cy="1234440"/>
           </a:xfrm>
           <a:prstGeom prst="rect">
@@ -50123,7 +50123,7 @@
         </p:nvSpPr>
         <p:spPr>
           <a:xfrm>
-            <a:off x="758952" y="4114800"/>
+            <a:off x="758952" y="4443984"/>
             <a:ext cx="1920240" cy="411480"/>
           </a:xfrm>
           <a:prstGeom prst="rect">
@@ -50162,7 +50162,7 @@
         </p:nvSpPr>
         <p:spPr>
           <a:xfrm>
-            <a:off x="2743200" y="4023360"/>
+            <a:off x="2743200" y="4352544"/>
             <a:ext cx="4178808" cy="1234440"/>
           </a:xfrm>
           <a:prstGeom prst="rect">
@@ -50201,7 +50201,7 @@
         </p:nvSpPr>
         <p:spPr>
           <a:xfrm>
-            <a:off x="502920" y="5422392"/>
+            <a:off x="502920" y="5824728"/>
             <a:ext cx="6556248" cy="1234440"/>
           </a:xfrm>
           <a:prstGeom prst="roundRect">
@@ -50247,7 +50247,7 @@
         </p:nvSpPr>
         <p:spPr>
           <a:xfrm>
-            <a:off x="502920" y="5422392"/>
+            <a:off x="502920" y="5824728"/>
             <a:ext cx="91440" cy="1234440"/>
           </a:xfrm>
           <a:prstGeom prst="rect">
@@ -50291,7 +50291,7 @@
         </p:nvSpPr>
         <p:spPr>
           <a:xfrm>
-            <a:off x="758952" y="5550407"/>
+            <a:off x="758952" y="5952744"/>
             <a:ext cx="1920240" cy="411480"/>
           </a:xfrm>
           <a:prstGeom prst="rect">
@@ -50330,7 +50330,7 @@
         </p:nvSpPr>
         <p:spPr>
           <a:xfrm>
-            <a:off x="2743200" y="5458968"/>
+            <a:off x="2743200" y="5861304"/>
             <a:ext cx="4178808" cy="1234440"/>
           </a:xfrm>
           <a:prstGeom prst="rect">
@@ -50369,7 +50369,7 @@
         </p:nvSpPr>
         <p:spPr>
           <a:xfrm>
-            <a:off x="502920" y="6858000"/>
+            <a:off x="502920" y="7333488"/>
             <a:ext cx="6556248" cy="1234440"/>
           </a:xfrm>
           <a:prstGeom prst="roundRect">
@@ -50415,7 +50415,7 @@
         </p:nvSpPr>
         <p:spPr>
           <a:xfrm>
-            <a:off x="502920" y="6858000"/>
+            <a:off x="502920" y="7333488"/>
             <a:ext cx="91440" cy="1234440"/>
           </a:xfrm>
           <a:prstGeom prst="rect">
@@ -50459,7 +50459,7 @@
         </p:nvSpPr>
         <p:spPr>
           <a:xfrm>
-            <a:off x="758952" y="6986016"/>
+            <a:off x="758952" y="7461504"/>
             <a:ext cx="1920240" cy="411480"/>
           </a:xfrm>
           <a:prstGeom prst="rect">
@@ -50498,7 +50498,7 @@
         </p:nvSpPr>
         <p:spPr>
           <a:xfrm>
-            <a:off x="2743200" y="6894576"/>
+            <a:off x="2743200" y="7370063"/>
             <a:ext cx="4178808" cy="1234440"/>
           </a:xfrm>
           <a:prstGeom prst="rect">
@@ -50537,7 +50537,7 @@
         </p:nvSpPr>
         <p:spPr>
           <a:xfrm>
-            <a:off x="502920" y="8293608"/>
+            <a:off x="502920" y="8842248"/>
             <a:ext cx="6556248" cy="1234440"/>
           </a:xfrm>
           <a:prstGeom prst="roundRect">
@@ -50583,7 +50583,7 @@
         </p:nvSpPr>
         <p:spPr>
           <a:xfrm>
-            <a:off x="502920" y="8293608"/>
+            <a:off x="502920" y="8842248"/>
             <a:ext cx="91440" cy="1234440"/>
           </a:xfrm>
           <a:prstGeom prst="rect">
@@ -50627,7 +50627,7 @@
         </p:nvSpPr>
         <p:spPr>
           <a:xfrm>
-            <a:off x="758952" y="8421624"/>
+            <a:off x="758952" y="8970264"/>
             <a:ext cx="1920240" cy="411480"/>
           </a:xfrm>
           <a:prstGeom prst="rect">
@@ -50666,7 +50666,7 @@
         </p:nvSpPr>
         <p:spPr>
           <a:xfrm>
-            <a:off x="2743200" y="8330183"/>
+            <a:off x="2743200" y="8878824"/>
             <a:ext cx="4178808" cy="1234440"/>
           </a:xfrm>
           <a:prstGeom prst="rect">
@@ -51004,7 +51004,7 @@
         </p:nvSpPr>
         <p:spPr>
           <a:xfrm>
-            <a:off x="502920" y="1481328"/>
+            <a:off x="502920" y="1645920"/>
             <a:ext cx="3177540" cy="1389888"/>
           </a:xfrm>
           <a:prstGeom prst="roundRect">
@@ -51050,7 +51050,7 @@
         </p:nvSpPr>
         <p:spPr>
           <a:xfrm>
-            <a:off x="502920" y="1481328"/>
+            <a:off x="502920" y="1645920"/>
             <a:ext cx="420624" cy="1389888"/>
           </a:xfrm>
           <a:prstGeom prst="roundRect">
@@ -51094,7 +51094,7 @@
         </p:nvSpPr>
         <p:spPr>
           <a:xfrm>
-            <a:off x="713232" y="1481328"/>
+            <a:off x="713232" y="1645920"/>
             <a:ext cx="210312" cy="1389888"/>
           </a:xfrm>
           <a:prstGeom prst="rect">
@@ -51138,7 +51138,7 @@
         </p:nvSpPr>
         <p:spPr>
           <a:xfrm>
-            <a:off x="539496" y="1984248"/>
+            <a:off x="539496" y="2148840"/>
             <a:ext cx="347472" cy="384048"/>
           </a:xfrm>
           <a:prstGeom prst="rect">
@@ -51177,7 +51177,7 @@
         </p:nvSpPr>
         <p:spPr>
           <a:xfrm>
-            <a:off x="1051560" y="1572768"/>
+            <a:off x="1051560" y="1737360"/>
             <a:ext cx="2500884" cy="329184"/>
           </a:xfrm>
           <a:prstGeom prst="rect">
@@ -51216,7 +51216,7 @@
         </p:nvSpPr>
         <p:spPr>
           <a:xfrm>
-            <a:off x="1051560" y="1956816"/>
+            <a:off x="1051560" y="2121408"/>
             <a:ext cx="2500884" cy="822960"/>
           </a:xfrm>
           <a:prstGeom prst="rect">
@@ -51255,7 +51255,7 @@
         </p:nvSpPr>
         <p:spPr>
           <a:xfrm>
-            <a:off x="3881628" y="1481328"/>
+            <a:off x="3881628" y="1645920"/>
             <a:ext cx="3177540" cy="1389888"/>
           </a:xfrm>
           <a:prstGeom prst="roundRect">
@@ -51301,7 +51301,7 @@
         </p:nvSpPr>
         <p:spPr>
           <a:xfrm>
-            <a:off x="3881628" y="1481328"/>
+            <a:off x="3881628" y="1645920"/>
             <a:ext cx="420624" cy="1389888"/>
           </a:xfrm>
           <a:prstGeom prst="roundRect">
@@ -51345,7 +51345,7 @@
         </p:nvSpPr>
         <p:spPr>
           <a:xfrm>
-            <a:off x="4091940" y="1481328"/>
+            <a:off x="4091940" y="1645920"/>
             <a:ext cx="210312" cy="1389888"/>
           </a:xfrm>
           <a:prstGeom prst="rect">
@@ -51389,7 +51389,7 @@
         </p:nvSpPr>
         <p:spPr>
           <a:xfrm>
-            <a:off x="3918204" y="1984248"/>
+            <a:off x="3918204" y="2148840"/>
             <a:ext cx="347472" cy="384048"/>
           </a:xfrm>
           <a:prstGeom prst="rect">
@@ -51428,7 +51428,7 @@
         </p:nvSpPr>
         <p:spPr>
           <a:xfrm>
-            <a:off x="4430268" y="1572768"/>
+            <a:off x="4430268" y="1737360"/>
             <a:ext cx="2500884" cy="329184"/>
           </a:xfrm>
           <a:prstGeom prst="rect">
@@ -51467,7 +51467,7 @@
         </p:nvSpPr>
         <p:spPr>
           <a:xfrm>
-            <a:off x="4430268" y="1956816"/>
+            <a:off x="4430268" y="2121408"/>
             <a:ext cx="2500884" cy="822960"/>
           </a:xfrm>
           <a:prstGeom prst="rect">
@@ -51506,7 +51506,7 @@
         </p:nvSpPr>
         <p:spPr>
           <a:xfrm>
-            <a:off x="502920" y="3035808"/>
+            <a:off x="502920" y="3456432"/>
             <a:ext cx="3177540" cy="1389888"/>
           </a:xfrm>
           <a:prstGeom prst="roundRect">
@@ -51552,7 +51552,7 @@
         </p:nvSpPr>
         <p:spPr>
           <a:xfrm>
-            <a:off x="502920" y="3035808"/>
+            <a:off x="502920" y="3456432"/>
             <a:ext cx="420624" cy="1389888"/>
           </a:xfrm>
           <a:prstGeom prst="roundRect">
@@ -51596,7 +51596,7 @@
         </p:nvSpPr>
         <p:spPr>
           <a:xfrm>
-            <a:off x="713232" y="3035808"/>
+            <a:off x="713232" y="3456432"/>
             <a:ext cx="210312" cy="1389888"/>
           </a:xfrm>
           <a:prstGeom prst="rect">
@@ -51640,7 +51640,7 @@
         </p:nvSpPr>
         <p:spPr>
           <a:xfrm>
-            <a:off x="539496" y="3538728"/>
+            <a:off x="539496" y="3959352"/>
             <a:ext cx="347472" cy="384048"/>
           </a:xfrm>
           <a:prstGeom prst="rect">
@@ -51679,7 +51679,7 @@
         </p:nvSpPr>
         <p:spPr>
           <a:xfrm>
-            <a:off x="1051560" y="3127248"/>
+            <a:off x="1051560" y="3547872"/>
             <a:ext cx="2500884" cy="329184"/>
           </a:xfrm>
           <a:prstGeom prst="rect">
@@ -51718,7 +51718,7 @@
         </p:nvSpPr>
         <p:spPr>
           <a:xfrm>
-            <a:off x="1051560" y="3511296"/>
+            <a:off x="1051560" y="3931920"/>
             <a:ext cx="2500884" cy="822960"/>
           </a:xfrm>
           <a:prstGeom prst="rect">
@@ -51757,7 +51757,7 @@
         </p:nvSpPr>
         <p:spPr>
           <a:xfrm>
-            <a:off x="3881628" y="3035808"/>
+            <a:off x="3881628" y="3456432"/>
             <a:ext cx="3177540" cy="1389888"/>
           </a:xfrm>
           <a:prstGeom prst="roundRect">
@@ -51803,7 +51803,7 @@
         </p:nvSpPr>
         <p:spPr>
           <a:xfrm>
-            <a:off x="3881628" y="3035808"/>
+            <a:off x="3881628" y="3456432"/>
             <a:ext cx="420624" cy="1389888"/>
           </a:xfrm>
           <a:prstGeom prst="roundRect">
@@ -51847,7 +51847,7 @@
         </p:nvSpPr>
         <p:spPr>
           <a:xfrm>
-            <a:off x="4091940" y="3035808"/>
+            <a:off x="4091940" y="3456432"/>
             <a:ext cx="210312" cy="1389888"/>
           </a:xfrm>
           <a:prstGeom prst="rect">
@@ -51891,7 +51891,7 @@
         </p:nvSpPr>
         <p:spPr>
           <a:xfrm>
-            <a:off x="3918204" y="3538728"/>
+            <a:off x="3918204" y="3959352"/>
             <a:ext cx="347472" cy="384048"/>
           </a:xfrm>
           <a:prstGeom prst="rect">
@@ -51930,7 +51930,7 @@
         </p:nvSpPr>
         <p:spPr>
           <a:xfrm>
-            <a:off x="4430268" y="3127248"/>
+            <a:off x="4430268" y="3547872"/>
             <a:ext cx="2500884" cy="329184"/>
           </a:xfrm>
           <a:prstGeom prst="rect">
@@ -51969,7 +51969,7 @@
         </p:nvSpPr>
         <p:spPr>
           <a:xfrm>
-            <a:off x="4430268" y="3511296"/>
+            <a:off x="4430268" y="3931920"/>
             <a:ext cx="2500884" cy="822960"/>
           </a:xfrm>
           <a:prstGeom prst="rect">
@@ -52008,7 +52008,7 @@
         </p:nvSpPr>
         <p:spPr>
           <a:xfrm>
-            <a:off x="502920" y="4590288"/>
+            <a:off x="502920" y="5266944"/>
             <a:ext cx="3177540" cy="1389888"/>
           </a:xfrm>
           <a:prstGeom prst="roundRect">
@@ -52054,7 +52054,7 @@
         </p:nvSpPr>
         <p:spPr>
           <a:xfrm>
-            <a:off x="502920" y="4590288"/>
+            <a:off x="502920" y="5266944"/>
             <a:ext cx="420624" cy="1389888"/>
           </a:xfrm>
           <a:prstGeom prst="roundRect">
@@ -52098,7 +52098,7 @@
         </p:nvSpPr>
         <p:spPr>
           <a:xfrm>
-            <a:off x="713232" y="4590288"/>
+            <a:off x="713232" y="5266944"/>
             <a:ext cx="210312" cy="1389888"/>
           </a:xfrm>
           <a:prstGeom prst="rect">
@@ -52142,7 +52142,7 @@
         </p:nvSpPr>
         <p:spPr>
           <a:xfrm>
-            <a:off x="539496" y="5093207"/>
+            <a:off x="539496" y="5769864"/>
             <a:ext cx="347472" cy="384048"/>
           </a:xfrm>
           <a:prstGeom prst="rect">
@@ -52181,7 +52181,7 @@
         </p:nvSpPr>
         <p:spPr>
           <a:xfrm>
-            <a:off x="1051560" y="4681727"/>
+            <a:off x="1051560" y="5358383"/>
             <a:ext cx="2500884" cy="329184"/>
           </a:xfrm>
           <a:prstGeom prst="rect">
@@ -52220,7 +52220,7 @@
         </p:nvSpPr>
         <p:spPr>
           <a:xfrm>
-            <a:off x="1051560" y="5065775"/>
+            <a:off x="1051560" y="5742431"/>
             <a:ext cx="2500884" cy="822960"/>
           </a:xfrm>
           <a:prstGeom prst="rect">
@@ -52259,7 +52259,7 @@
         </p:nvSpPr>
         <p:spPr>
           <a:xfrm>
-            <a:off x="3881628" y="4590288"/>
+            <a:off x="3881628" y="5266944"/>
             <a:ext cx="3177540" cy="1389888"/>
           </a:xfrm>
           <a:prstGeom prst="roundRect">
@@ -52305,7 +52305,7 @@
         </p:nvSpPr>
         <p:spPr>
           <a:xfrm>
-            <a:off x="3881628" y="4590288"/>
+            <a:off x="3881628" y="5266944"/>
             <a:ext cx="420624" cy="1389888"/>
           </a:xfrm>
           <a:prstGeom prst="roundRect">
@@ -52349,7 +52349,7 @@
         </p:nvSpPr>
         <p:spPr>
           <a:xfrm>
-            <a:off x="4091940" y="4590288"/>
+            <a:off x="4091940" y="5266944"/>
             <a:ext cx="210312" cy="1389888"/>
           </a:xfrm>
           <a:prstGeom prst="rect">
@@ -52393,7 +52393,7 @@
         </p:nvSpPr>
         <p:spPr>
           <a:xfrm>
-            <a:off x="3918204" y="5093207"/>
+            <a:off x="3918204" y="5769864"/>
             <a:ext cx="347472" cy="384048"/>
           </a:xfrm>
           <a:prstGeom prst="rect">
@@ -52432,7 +52432,7 @@
         </p:nvSpPr>
         <p:spPr>
           <a:xfrm>
-            <a:off x="4430268" y="4681727"/>
+            <a:off x="4430268" y="5358383"/>
             <a:ext cx="2500884" cy="329184"/>
           </a:xfrm>
           <a:prstGeom prst="rect">
@@ -52471,7 +52471,7 @@
         </p:nvSpPr>
         <p:spPr>
           <a:xfrm>
-            <a:off x="4430268" y="5065775"/>
+            <a:off x="4430268" y="5742431"/>
             <a:ext cx="2500884" cy="822960"/>
           </a:xfrm>
           <a:prstGeom prst="rect">
@@ -52510,7 +52510,7 @@
         </p:nvSpPr>
         <p:spPr>
           <a:xfrm>
-            <a:off x="502920" y="6144768"/>
+            <a:off x="502920" y="7077455"/>
             <a:ext cx="3177540" cy="1389888"/>
           </a:xfrm>
           <a:prstGeom prst="roundRect">
@@ -52556,7 +52556,7 @@
         </p:nvSpPr>
         <p:spPr>
           <a:xfrm>
-            <a:off x="502920" y="6144768"/>
+            <a:off x="502920" y="7077455"/>
             <a:ext cx="420624" cy="1389888"/>
           </a:xfrm>
           <a:prstGeom prst="roundRect">
@@ -52600,7 +52600,7 @@
         </p:nvSpPr>
         <p:spPr>
           <a:xfrm>
-            <a:off x="713232" y="6144768"/>
+            <a:off x="713232" y="7077455"/>
             <a:ext cx="210312" cy="1389888"/>
           </a:xfrm>
           <a:prstGeom prst="rect">
@@ -52644,7 +52644,7 @@
         </p:nvSpPr>
         <p:spPr>
           <a:xfrm>
-            <a:off x="539496" y="6647688"/>
+            <a:off x="539496" y="7580375"/>
             <a:ext cx="347472" cy="384048"/>
           </a:xfrm>
           <a:prstGeom prst="rect">
@@ -52683,7 +52683,7 @@
         </p:nvSpPr>
         <p:spPr>
           <a:xfrm>
-            <a:off x="1051560" y="6236207"/>
+            <a:off x="1051560" y="7168895"/>
             <a:ext cx="2500884" cy="329184"/>
           </a:xfrm>
           <a:prstGeom prst="rect">
@@ -52722,7 +52722,7 @@
         </p:nvSpPr>
         <p:spPr>
           <a:xfrm>
-            <a:off x="1051560" y="6620256"/>
+            <a:off x="1051560" y="7552944"/>
             <a:ext cx="2500884" cy="822960"/>
           </a:xfrm>
           <a:prstGeom prst="rect">
@@ -52761,7 +52761,7 @@
         </p:nvSpPr>
         <p:spPr>
           <a:xfrm>
-            <a:off x="3881628" y="6144768"/>
+            <a:off x="3881628" y="7077455"/>
             <a:ext cx="3177540" cy="1389888"/>
           </a:xfrm>
           <a:prstGeom prst="roundRect">
@@ -52807,7 +52807,7 @@
         </p:nvSpPr>
         <p:spPr>
           <a:xfrm>
-            <a:off x="3881628" y="6144768"/>
+            <a:off x="3881628" y="7077455"/>
             <a:ext cx="420624" cy="1389888"/>
           </a:xfrm>
           <a:prstGeom prst="roundRect">
@@ -52851,7 +52851,7 @@
         </p:nvSpPr>
         <p:spPr>
           <a:xfrm>
-            <a:off x="4091940" y="6144768"/>
+            <a:off x="4091940" y="7077455"/>
             <a:ext cx="210312" cy="1389888"/>
           </a:xfrm>
           <a:prstGeom prst="rect">
@@ -52895,7 +52895,7 @@
         </p:nvSpPr>
         <p:spPr>
           <a:xfrm>
-            <a:off x="3918204" y="6647688"/>
+            <a:off x="3918204" y="7580375"/>
             <a:ext cx="347472" cy="384048"/>
           </a:xfrm>
           <a:prstGeom prst="rect">
@@ -52934,7 +52934,7 @@
         </p:nvSpPr>
         <p:spPr>
           <a:xfrm>
-            <a:off x="4430268" y="6236207"/>
+            <a:off x="4430268" y="7168895"/>
             <a:ext cx="2500884" cy="329184"/>
           </a:xfrm>
           <a:prstGeom prst="rect">
@@ -52973,7 +52973,7 @@
         </p:nvSpPr>
         <p:spPr>
           <a:xfrm>
-            <a:off x="4430268" y="6620256"/>
+            <a:off x="4430268" y="7552944"/>
             <a:ext cx="2500884" cy="822960"/>
           </a:xfrm>
           <a:prstGeom prst="rect">

</xml_diff>